<commit_message>
Deal Desk deck: Space Grotesk font, shorter titles
Co-Authored-By: Claude Opus 5.5 <noreply@anthropic.com>
</commit_message>
<xml_diff>
--- a/docs/Deal-Desk.pptx
+++ b/docs/Deal-Desk.pptx
@@ -2005,9 +2005,9 @@
                 <a:solidFill>
                   <a:srgbClr val="26231F"/>
                 </a:solidFill>
-                <a:latin typeface="Arial" pitchFamily="34" charset="0"/>
-                <a:ea typeface="Arial" pitchFamily="34" charset="-122"/>
-                <a:cs typeface="Arial" pitchFamily="34" charset="-120"/>
+                <a:latin typeface="Space Grotesk" pitchFamily="34" charset="0"/>
+                <a:ea typeface="Space Grotesk" pitchFamily="34" charset="-122"/>
+                <a:cs typeface="Space Grotesk" pitchFamily="34" charset="-120"/>
               </a:rPr>
               <a:t>DEAL DESK</a:t>
             </a:r>
@@ -2044,9 +2044,9 @@
                 <a:solidFill>
                   <a:srgbClr val="5F5A52"/>
                 </a:solidFill>
-                <a:latin typeface="Arial" pitchFamily="34" charset="0"/>
-                <a:ea typeface="Arial" pitchFamily="34" charset="-122"/>
-                <a:cs typeface="Arial" pitchFamily="34" charset="-120"/>
+                <a:latin typeface="Space Grotesk" pitchFamily="34" charset="0"/>
+                <a:ea typeface="Space Grotesk" pitchFamily="34" charset="-122"/>
+                <a:cs typeface="Space Grotesk" pitchFamily="34" charset="-120"/>
               </a:rPr>
               <a:t>Ask a senior about a live deal.</a:t>
             </a:r>
@@ -2061,9 +2061,9 @@
                 <a:solidFill>
                   <a:srgbClr val="5F5A52"/>
                 </a:solidFill>
-                <a:latin typeface="Arial" pitchFamily="34" charset="0"/>
-                <a:ea typeface="Arial" pitchFamily="34" charset="-122"/>
-                <a:cs typeface="Arial" pitchFamily="34" charset="-120"/>
+                <a:latin typeface="Space Grotesk" pitchFamily="34" charset="0"/>
+                <a:ea typeface="Space Grotesk" pitchFamily="34" charset="-122"/>
+                <a:cs typeface="Space Grotesk" pitchFamily="34" charset="-120"/>
               </a:rPr>
               <a:t>Nobody knows it was you.</a:t>
             </a:r>
@@ -2127,9 +2127,9 @@
                 <a:solidFill>
                   <a:srgbClr val="FFFFFF"/>
                 </a:solidFill>
-                <a:latin typeface="Arial" pitchFamily="34" charset="0"/>
-                <a:ea typeface="Arial" pitchFamily="34" charset="-122"/>
-                <a:cs typeface="Arial" pitchFamily="34" charset="-120"/>
+                <a:latin typeface="Space Grotesk" pitchFamily="34" charset="0"/>
+                <a:ea typeface="Space Grotesk" pitchFamily="34" charset="-122"/>
+                <a:cs typeface="Space Grotesk" pitchFamily="34" charset="-120"/>
               </a:rPr>
               <a:t>Live demo inside</a:t>
             </a:r>
@@ -2166,9 +2166,9 @@
                 <a:solidFill>
                   <a:srgbClr val="9A9387"/>
                 </a:solidFill>
-                <a:latin typeface="Arial" pitchFamily="34" charset="0"/>
-                <a:ea typeface="Arial" pitchFamily="34" charset="-122"/>
-                <a:cs typeface="Arial" pitchFamily="34" charset="-120"/>
+                <a:latin typeface="Space Grotesk" pitchFamily="34" charset="0"/>
+                <a:ea typeface="Space Grotesk" pitchFamily="34" charset="-122"/>
+                <a:cs typeface="Space Grotesk" pitchFamily="34" charset="-120"/>
               </a:rPr>
               <a:t>Talk to Users hackathon · San Francisco · Oct 10, 2026</a:t>
             </a:r>
@@ -2237,9 +2237,9 @@
                 <a:solidFill>
                   <a:srgbClr val="FFFFFF"/>
                 </a:solidFill>
-                <a:latin typeface="Arial" pitchFamily="34" charset="0"/>
-                <a:ea typeface="Arial" pitchFamily="34" charset="-122"/>
-                <a:cs typeface="Arial" pitchFamily="34" charset="-120"/>
+                <a:latin typeface="Space Grotesk" pitchFamily="34" charset="0"/>
+                <a:ea typeface="Space Grotesk" pitchFamily="34" charset="-122"/>
+                <a:cs typeface="Space Grotesk" pitchFamily="34" charset="-120"/>
               </a:rPr>
               <a:t>TRY IT NOW</a:t>
             </a:r>
@@ -2276,9 +2276,9 @@
                 <a:solidFill>
                   <a:srgbClr val="D9D2C5"/>
                 </a:solidFill>
-                <a:latin typeface="Arial" pitchFamily="34" charset="0"/>
-                <a:ea typeface="Arial" pitchFamily="34" charset="-122"/>
-                <a:cs typeface="Arial" pitchFamily="34" charset="-120"/>
+                <a:latin typeface="Space Grotesk" pitchFamily="34" charset="0"/>
+                <a:ea typeface="Space Grotesk" pitchFamily="34" charset="-122"/>
+                <a:cs typeface="Space Grotesk" pitchFamily="34" charset="-120"/>
               </a:rPr>
               <a:t>Log in as a junior in one tab and a senior in another. Ask, answer, and watch the result come back.</a:t>
             </a:r>
@@ -2317,9 +2317,9 @@
                 <a:solidFill>
                   <a:srgbClr val="FF7A2F"/>
                 </a:solidFill>
-                <a:latin typeface="Arial" pitchFamily="34" charset="0"/>
-                <a:ea typeface="Arial" pitchFamily="34" charset="-122"/>
-                <a:cs typeface="Arial" pitchFamily="34" charset="-120"/>
+                <a:latin typeface="Space Grotesk" pitchFamily="34" charset="0"/>
+                <a:ea typeface="Space Grotesk" pitchFamily="34" charset="-122"/>
+                <a:cs typeface="Space Grotesk" pitchFamily="34" charset="-120"/>
                 <a:hlinkClick r:id="rId1" invalidUrl="" action="" tgtFrame="" tooltip="" history="1" highlightClick="0" endSnd="0">
                   <a:extLst>
                     <a:ext uri="{A12FA001-AC4F-418D-AE19-62706E023703}">
@@ -2414,9 +2414,9 @@
                 <a:solidFill>
                   <a:srgbClr val="D9D2C5"/>
                 </a:solidFill>
-                <a:latin typeface="Arial" pitchFamily="34" charset="0"/>
-                <a:ea typeface="Arial" pitchFamily="34" charset="-122"/>
-                <a:cs typeface="Arial" pitchFamily="34" charset="-120"/>
+                <a:latin typeface="Space Grotesk" pitchFamily="34" charset="0"/>
+                <a:ea typeface="Space Grotesk" pitchFamily="34" charset="-122"/>
+                <a:cs typeface="Space Grotesk" pitchFamily="34" charset="-120"/>
               </a:rPr>
               <a:t>Scan to open Deal Desk</a:t>
             </a:r>
@@ -2485,9 +2485,9 @@
                 <a:solidFill>
                   <a:srgbClr val="FF7A2F"/>
                 </a:solidFill>
-                <a:latin typeface="Arial" pitchFamily="34" charset="0"/>
-                <a:ea typeface="Arial" pitchFamily="34" charset="-122"/>
-                <a:cs typeface="Arial" pitchFamily="34" charset="-120"/>
+                <a:latin typeface="Space Grotesk" pitchFamily="34" charset="0"/>
+                <a:ea typeface="Space Grotesk" pitchFamily="34" charset="-122"/>
+                <a:cs typeface="Space Grotesk" pitchFamily="34" charset="-120"/>
               </a:rPr>
               <a:t>THE PROBLEM</a:t>
             </a:r>
@@ -2524,9 +2524,9 @@
                 <a:solidFill>
                   <a:srgbClr val="FFFFFF"/>
                 </a:solidFill>
-                <a:latin typeface="Arial" pitchFamily="34" charset="0"/>
-                <a:ea typeface="Arial" pitchFamily="34" charset="-122"/>
-                <a:cs typeface="Arial" pitchFamily="34" charset="-120"/>
+                <a:latin typeface="Space Grotesk" pitchFamily="34" charset="0"/>
+                <a:ea typeface="Space Grotesk" pitchFamily="34" charset="-122"/>
+                <a:cs typeface="Space Grotesk" pitchFamily="34" charset="-120"/>
               </a:rPr>
               <a:t>Most acquisitions miss the goals the buyer set for them</a:t>
             </a:r>
@@ -2563,9 +2563,9 @@
                 <a:solidFill>
                   <a:srgbClr val="FF7A2F"/>
                 </a:solidFill>
-                <a:latin typeface="Arial" pitchFamily="34" charset="0"/>
-                <a:ea typeface="Arial" pitchFamily="34" charset="-122"/>
-                <a:cs typeface="Arial" pitchFamily="34" charset="-120"/>
+                <a:latin typeface="Space Grotesk" pitchFamily="34" charset="0"/>
+                <a:ea typeface="Space Grotesk" pitchFamily="34" charset="-122"/>
+                <a:cs typeface="Space Grotesk" pitchFamily="34" charset="-120"/>
               </a:rPr>
               <a:t>70–75%</a:t>
             </a:r>
@@ -2602,9 +2602,9 @@
                 <a:solidFill>
                   <a:srgbClr val="E9E3D7"/>
                 </a:solidFill>
-                <a:latin typeface="Arial" pitchFamily="34" charset="0"/>
-                <a:ea typeface="Arial" pitchFamily="34" charset="-122"/>
-                <a:cs typeface="Arial" pitchFamily="34" charset="-120"/>
+                <a:latin typeface="Space Grotesk" pitchFamily="34" charset="0"/>
+                <a:ea typeface="Space Grotesk" pitchFamily="34" charset="-122"/>
+                <a:cs typeface="Space Grotesk" pitchFamily="34" charset="-120"/>
               </a:rPr>
               <a:t>of acquisitions fail to deliver their stated goals, across roughly 40,000 deals over 40 years¹</a:t>
             </a:r>
@@ -2671,9 +2671,9 @@
                 <a:solidFill>
                   <a:srgbClr val="FFFFFF"/>
                 </a:solidFill>
-                <a:latin typeface="Arial" pitchFamily="34" charset="0"/>
-                <a:ea typeface="Arial" pitchFamily="34" charset="-122"/>
-                <a:cs typeface="Arial" pitchFamily="34" charset="-120"/>
+                <a:latin typeface="Space Grotesk" pitchFamily="34" charset="0"/>
+                <a:ea typeface="Space Grotesk" pitchFamily="34" charset="-122"/>
+                <a:cs typeface="Space Grotesk" pitchFamily="34" charset="-120"/>
               </a:rPr>
               <a:t>The people closest to the work</a:t>
             </a:r>
@@ -2691,9 +2691,9 @@
                 <a:solidFill>
                   <a:srgbClr val="D9D2C5"/>
                 </a:solidFill>
-                <a:latin typeface="Arial" pitchFamily="34" charset="0"/>
-                <a:ea typeface="Arial" pitchFamily="34" charset="-122"/>
-                <a:cs typeface="Arial" pitchFamily="34" charset="-120"/>
+                <a:latin typeface="Space Grotesk" pitchFamily="34" charset="0"/>
+                <a:ea typeface="Space Grotesk" pitchFamily="34" charset="-122"/>
+                <a:cs typeface="Space Grotesk" pitchFamily="34" charset="-120"/>
               </a:rPr>
               <a:t>Analysts and associates build the models and read the documents, and they are the least likely to ask when something looks wrong.</a:t>
             </a:r>
@@ -2730,9 +2730,9 @@
                 <a:solidFill>
                   <a:srgbClr val="8C857A"/>
                 </a:solidFill>
-                <a:latin typeface="Arial" pitchFamily="34" charset="0"/>
-                <a:ea typeface="Arial" pitchFamily="34" charset="-122"/>
-                <a:cs typeface="Arial" pitchFamily="34" charset="-120"/>
+                <a:latin typeface="Space Grotesk" pitchFamily="34" charset="0"/>
+                <a:ea typeface="Space Grotesk" pitchFamily="34" charset="-122"/>
+                <a:cs typeface="Space Grotesk" pitchFamily="34" charset="-120"/>
               </a:rPr>
               <a:t>¹ Baruch Lev and Feng Gu, analysis of ~40,000 acquisitions, reported in Fortune, Nov 2024.</a:t>
             </a:r>
@@ -2801,9 +2801,9 @@
                 <a:solidFill>
                   <a:srgbClr val="FF7A2F"/>
                 </a:solidFill>
-                <a:latin typeface="Arial" pitchFamily="34" charset="0"/>
-                <a:ea typeface="Arial" pitchFamily="34" charset="-122"/>
-                <a:cs typeface="Arial" pitchFamily="34" charset="-120"/>
+                <a:latin typeface="Space Grotesk" pitchFamily="34" charset="0"/>
+                <a:ea typeface="Space Grotesk" pitchFamily="34" charset="-122"/>
+                <a:cs typeface="Space Grotesk" pitchFamily="34" charset="-120"/>
               </a:rPr>
               <a:t>WHY PEOPLE STAY QUIET</a:t>
             </a:r>
@@ -2840,9 +2840,9 @@
                 <a:solidFill>
                   <a:srgbClr val="26231F"/>
                 </a:solidFill>
-                <a:latin typeface="Arial" pitchFamily="34" charset="0"/>
-                <a:ea typeface="Arial" pitchFamily="34" charset="-122"/>
-                <a:cs typeface="Arial" pitchFamily="34" charset="-120"/>
+                <a:latin typeface="Space Grotesk" pitchFamily="34" charset="0"/>
+                <a:ea typeface="Space Grotesk" pitchFamily="34" charset="-122"/>
+                <a:cs typeface="Space Grotesk" pitchFamily="34" charset="-120"/>
               </a:rPr>
               <a:t>Young staff are almost 3x as likely to feel awkward asking for help</a:t>
             </a:r>
@@ -2963,9 +2963,9 @@
                 <a:solidFill>
                   <a:srgbClr val="FF7A2F"/>
                 </a:solidFill>
-                <a:latin typeface="Arial" pitchFamily="34" charset="0"/>
-                <a:ea typeface="Arial" pitchFamily="34" charset="-122"/>
-                <a:cs typeface="Arial" pitchFamily="34" charset="-120"/>
+                <a:latin typeface="Space Grotesk" pitchFamily="34" charset="0"/>
+                <a:ea typeface="Space Grotesk" pitchFamily="34" charset="-122"/>
+                <a:cs typeface="Space Grotesk" pitchFamily="34" charset="-120"/>
               </a:rPr>
               <a:t>26%</a:t>
             </a:r>
@@ -2980,9 +2980,9 @@
                 <a:solidFill>
                   <a:srgbClr val="26231F"/>
                 </a:solidFill>
-                <a:latin typeface="Arial" pitchFamily="34" charset="0"/>
-                <a:ea typeface="Arial" pitchFamily="34" charset="-122"/>
-                <a:cs typeface="Arial" pitchFamily="34" charset="-120"/>
+                <a:latin typeface="Space Grotesk" pitchFamily="34" charset="0"/>
+                <a:ea typeface="Space Grotesk" pitchFamily="34" charset="-122"/>
+                <a:cs typeface="Space Grotesk" pitchFamily="34" charset="-120"/>
               </a:rPr>
               <a:t>of leaders make their teams feel safe to speak up²</a:t>
             </a:r>
@@ -3053,9 +3053,9 @@
                 <a:solidFill>
                   <a:srgbClr val="FF7A2F"/>
                 </a:solidFill>
-                <a:latin typeface="Arial" pitchFamily="34" charset="0"/>
-                <a:ea typeface="Arial" pitchFamily="34" charset="-122"/>
-                <a:cs typeface="Arial" pitchFamily="34" charset="-120"/>
+                <a:latin typeface="Space Grotesk" pitchFamily="34" charset="0"/>
+                <a:ea typeface="Space Grotesk" pitchFamily="34" charset="-122"/>
+                <a:cs typeface="Space Grotesk" pitchFamily="34" charset="-120"/>
               </a:rPr>
               <a:t>#1</a:t>
             </a:r>
@@ -3070,9 +3070,9 @@
                 <a:solidFill>
                   <a:srgbClr val="26231F"/>
                 </a:solidFill>
-                <a:latin typeface="Arial" pitchFamily="34" charset="0"/>
-                <a:ea typeface="Arial" pitchFamily="34" charset="-122"/>
-                <a:cs typeface="Arial" pitchFamily="34" charset="-120"/>
+                <a:latin typeface="Space Grotesk" pitchFamily="34" charset="0"/>
+                <a:ea typeface="Space Grotesk" pitchFamily="34" charset="-122"/>
+                <a:cs typeface="Space Grotesk" pitchFamily="34" charset="-120"/>
               </a:rPr>
               <a:t>Feeling safe to speak up was the top trait of Google's best teams, out of 180 studied³</a:t>
             </a:r>
@@ -3109,9 +3109,9 @@
                 <a:solidFill>
                   <a:srgbClr val="9A9387"/>
                 </a:solidFill>
-                <a:latin typeface="Arial" pitchFamily="34" charset="0"/>
-                <a:ea typeface="Arial" pitchFamily="34" charset="-122"/>
-                <a:cs typeface="Arial" pitchFamily="34" charset="-120"/>
+                <a:latin typeface="Space Grotesk" pitchFamily="34" charset="0"/>
+                <a:ea typeface="Space Grotesk" pitchFamily="34" charset="-122"/>
+                <a:cs typeface="Space Grotesk" pitchFamily="34" charset="-120"/>
               </a:rPr>
               <a:t>¹ UK workplace survey, 2012 (BHP). ² McKinsey Global Survey, 2021. ³ Google Project Aristotle, 2012–2014.</a:t>
             </a:r>
@@ -3180,9 +3180,9 @@
                 <a:solidFill>
                   <a:srgbClr val="FF7A2F"/>
                 </a:solidFill>
-                <a:latin typeface="Arial" pitchFamily="34" charset="0"/>
-                <a:ea typeface="Arial" pitchFamily="34" charset="-122"/>
-                <a:cs typeface="Arial" pitchFamily="34" charset="-120"/>
+                <a:latin typeface="Space Grotesk" pitchFamily="34" charset="0"/>
+                <a:ea typeface="Space Grotesk" pitchFamily="34" charset="-122"/>
+                <a:cs typeface="Space Grotesk" pitchFamily="34" charset="-120"/>
               </a:rPr>
               <a:t>WHAT BANKERS DO INSTEAD</a:t>
             </a:r>
@@ -3219,11 +3219,11 @@
                 <a:solidFill>
                   <a:srgbClr val="26231F"/>
                 </a:solidFill>
-                <a:latin typeface="Arial" pitchFamily="34" charset="0"/>
-                <a:ea typeface="Arial" pitchFamily="34" charset="-122"/>
-                <a:cs typeface="Arial" pitchFamily="34" charset="-120"/>
-              </a:rPr>
-              <a:t>Bankers already go around official channels, and regulators charge for it</a:t>
+                <a:latin typeface="Space Grotesk" pitchFamily="34" charset="0"/>
+                <a:ea typeface="Space Grotesk" pitchFamily="34" charset="-122"/>
+                <a:cs typeface="Space Grotesk" pitchFamily="34" charset="-120"/>
+              </a:rPr>
+              <a:t>Bankers already go around official channels, and regulators fine them</a:t>
             </a:r>
             <a:endParaRPr lang="en-US" sz="2800" dirty="0"/>
           </a:p>
@@ -3258,9 +3258,9 @@
                 <a:solidFill>
                   <a:srgbClr val="FF7A2F"/>
                 </a:solidFill>
-                <a:latin typeface="Arial" pitchFamily="34" charset="0"/>
-                <a:ea typeface="Arial" pitchFamily="34" charset="-122"/>
-                <a:cs typeface="Arial" pitchFamily="34" charset="-120"/>
+                <a:latin typeface="Space Grotesk" pitchFamily="34" charset="0"/>
+                <a:ea typeface="Space Grotesk" pitchFamily="34" charset="-122"/>
+                <a:cs typeface="Space Grotesk" pitchFamily="34" charset="-120"/>
               </a:rPr>
               <a:t>$2.5B+</a:t>
             </a:r>
@@ -3297,9 +3297,9 @@
                 <a:solidFill>
                   <a:srgbClr val="26231F"/>
                 </a:solidFill>
-                <a:latin typeface="Arial" pitchFamily="34" charset="0"/>
-                <a:ea typeface="Arial" pitchFamily="34" charset="-122"/>
-                <a:cs typeface="Arial" pitchFamily="34" charset="-120"/>
+                <a:latin typeface="Space Grotesk" pitchFamily="34" charset="0"/>
+                <a:ea typeface="Space Grotesk" pitchFamily="34" charset="-122"/>
+                <a:cs typeface="Space Grotesk" pitchFamily="34" charset="-120"/>
               </a:rPr>
               <a:t>in SEC and CFTC fines since Dec 2021 for work talk on WhatsApp and texts that firms never recorded¹</a:t>
             </a:r>
@@ -3395,9 +3395,9 @@
                 <a:solidFill>
                   <a:srgbClr val="FFFFFF"/>
                 </a:solidFill>
-                <a:latin typeface="Arial" pitchFamily="34" charset="0"/>
-                <a:ea typeface="Arial" pitchFamily="34" charset="-122"/>
-                <a:cs typeface="Arial" pitchFamily="34" charset="-120"/>
+                <a:latin typeface="Space Grotesk" pitchFamily="34" charset="0"/>
+                <a:ea typeface="Space Grotesk" pitchFamily="34" charset="-122"/>
+                <a:cs typeface="Space Grotesk" pitchFamily="34" charset="-120"/>
               </a:rPr>
               <a:t>1</a:t>
             </a:r>
@@ -3434,9 +3434,9 @@
                 <a:solidFill>
                   <a:srgbClr val="26231F"/>
                 </a:solidFill>
-                <a:latin typeface="Arial" pitchFamily="34" charset="0"/>
-                <a:ea typeface="Arial" pitchFamily="34" charset="-122"/>
-                <a:cs typeface="Arial" pitchFamily="34" charset="-120"/>
+                <a:latin typeface="Space Grotesk" pitchFamily="34" charset="0"/>
+                <a:ea typeface="Space Grotesk" pitchFamily="34" charset="-122"/>
+                <a:cs typeface="Space Grotesk" pitchFamily="34" charset="-120"/>
               </a:rPr>
               <a:t>30+ firms fined</a:t>
             </a:r>
@@ -3451,9 +3451,9 @@
                 <a:solidFill>
                   <a:srgbClr val="5F5A52"/>
                 </a:solidFill>
-                <a:latin typeface="Arial" pitchFamily="34" charset="0"/>
-                <a:ea typeface="Arial" pitchFamily="34" charset="-122"/>
-                <a:cs typeface="Arial" pitchFamily="34" charset="-120"/>
+                <a:latin typeface="Space Grotesk" pitchFamily="34" charset="0"/>
+                <a:ea typeface="Space Grotesk" pitchFamily="34" charset="-122"/>
+                <a:cs typeface="Space Grotesk" pitchFamily="34" charset="-120"/>
               </a:rPr>
               <a:t>including JPMorgan, Goldman Sachs and Citi</a:t>
             </a:r>
@@ -3515,9 +3515,9 @@
                 <a:solidFill>
                   <a:srgbClr val="FFFFFF"/>
                 </a:solidFill>
-                <a:latin typeface="Arial" pitchFamily="34" charset="0"/>
-                <a:ea typeface="Arial" pitchFamily="34" charset="-122"/>
-                <a:cs typeface="Arial" pitchFamily="34" charset="-120"/>
+                <a:latin typeface="Space Grotesk" pitchFamily="34" charset="0"/>
+                <a:ea typeface="Space Grotesk" pitchFamily="34" charset="-122"/>
+                <a:cs typeface="Space Grotesk" pitchFamily="34" charset="-120"/>
               </a:rPr>
               <a:t>2</a:t>
             </a:r>
@@ -3554,9 +3554,9 @@
                 <a:solidFill>
                   <a:srgbClr val="26231F"/>
                 </a:solidFill>
-                <a:latin typeface="Arial" pitchFamily="34" charset="0"/>
-                <a:ea typeface="Arial" pitchFamily="34" charset="-122"/>
-                <a:cs typeface="Arial" pitchFamily="34" charset="-120"/>
+                <a:latin typeface="Space Grotesk" pitchFamily="34" charset="0"/>
+                <a:ea typeface="Space Grotesk" pitchFamily="34" charset="-122"/>
+                <a:cs typeface="Space Grotesk" pitchFamily="34" charset="-120"/>
               </a:rPr>
               <a:t>Private chats are where the real questions go</a:t>
             </a:r>
@@ -3571,9 +3571,9 @@
                 <a:solidFill>
                   <a:srgbClr val="5F5A52"/>
                 </a:solidFill>
-                <a:latin typeface="Arial" pitchFamily="34" charset="0"/>
-                <a:ea typeface="Arial" pitchFamily="34" charset="-122"/>
-                <a:cs typeface="Arial" pitchFamily="34" charset="-120"/>
+                <a:latin typeface="Space Grotesk" pitchFamily="34" charset="0"/>
+                <a:ea typeface="Space Grotesk" pitchFamily="34" charset="-122"/>
+                <a:cs typeface="Space Grotesk" pitchFamily="34" charset="-120"/>
               </a:rPr>
               <a:t>because they feel safe</a:t>
             </a:r>
@@ -3635,9 +3635,9 @@
                 <a:solidFill>
                   <a:srgbClr val="FFFFFF"/>
                 </a:solidFill>
-                <a:latin typeface="Arial" pitchFamily="34" charset="0"/>
-                <a:ea typeface="Arial" pitchFamily="34" charset="-122"/>
-                <a:cs typeface="Arial" pitchFamily="34" charset="-120"/>
+                <a:latin typeface="Space Grotesk" pitchFamily="34" charset="0"/>
+                <a:ea typeface="Space Grotesk" pitchFamily="34" charset="-122"/>
+                <a:cs typeface="Space Grotesk" pitchFamily="34" charset="-120"/>
               </a:rPr>
               <a:t>3</a:t>
             </a:r>
@@ -3674,9 +3674,9 @@
                 <a:solidFill>
                   <a:srgbClr val="26231F"/>
                 </a:solidFill>
-                <a:latin typeface="Arial" pitchFamily="34" charset="0"/>
-                <a:ea typeface="Arial" pitchFamily="34" charset="-122"/>
-                <a:cs typeface="Arial" pitchFamily="34" charset="-120"/>
+                <a:latin typeface="Space Grotesk" pitchFamily="34" charset="0"/>
+                <a:ea typeface="Space Grotesk" pitchFamily="34" charset="-122"/>
+                <a:cs typeface="Space Grotesk" pitchFamily="34" charset="-120"/>
               </a:rPr>
               <a:t>Deal Desk keeps the safety</a:t>
             </a:r>
@@ -3691,9 +3691,9 @@
                 <a:solidFill>
                   <a:srgbClr val="5F5A52"/>
                 </a:solidFill>
-                <a:latin typeface="Arial" pitchFamily="34" charset="0"/>
-                <a:ea typeface="Arial" pitchFamily="34" charset="-122"/>
-                <a:cs typeface="Arial" pitchFamily="34" charset="-120"/>
+                <a:latin typeface="Space Grotesk" pitchFamily="34" charset="0"/>
+                <a:ea typeface="Space Grotesk" pitchFamily="34" charset="-122"/>
+                <a:cs typeface="Space Grotesk" pitchFamily="34" charset="-120"/>
               </a:rPr>
               <a:t>and adds a sealed record for compliance</a:t>
             </a:r>
@@ -3730,9 +3730,9 @@
                 <a:solidFill>
                   <a:srgbClr val="9A9387"/>
                 </a:solidFill>
-                <a:latin typeface="Arial" pitchFamily="34" charset="0"/>
-                <a:ea typeface="Arial" pitchFamily="34" charset="-122"/>
-                <a:cs typeface="Arial" pitchFamily="34" charset="-120"/>
+                <a:latin typeface="Space Grotesk" pitchFamily="34" charset="0"/>
+                <a:ea typeface="Space Grotesk" pitchFamily="34" charset="-122"/>
+                <a:cs typeface="Space Grotesk" pitchFamily="34" charset="-120"/>
               </a:rPr>
               <a:t>¹ InvestmentNews and Bloomberg reporting on SEC/CFTC recordkeeping settlements, Dec 2021 – Aug 2023.</a:t>
             </a:r>
@@ -3801,9 +3801,9 @@
                 <a:solidFill>
                   <a:srgbClr val="FF7A2F"/>
                 </a:solidFill>
-                <a:latin typeface="Arial" pitchFamily="34" charset="0"/>
-                <a:ea typeface="Arial" pitchFamily="34" charset="-122"/>
-                <a:cs typeface="Arial" pitchFamily="34" charset="-120"/>
+                <a:latin typeface="Space Grotesk" pitchFamily="34" charset="0"/>
+                <a:ea typeface="Space Grotesk" pitchFamily="34" charset="-122"/>
+                <a:cs typeface="Space Grotesk" pitchFamily="34" charset="-120"/>
               </a:rPr>
               <a:t>HOW IT WORKS</a:t>
             </a:r>
@@ -3840,11 +3840,11 @@
                 <a:solidFill>
                   <a:srgbClr val="26231F"/>
                 </a:solidFill>
-                <a:latin typeface="Arial" pitchFamily="34" charset="0"/>
-                <a:ea typeface="Arial" pitchFamily="34" charset="-122"/>
-                <a:cs typeface="Arial" pitchFamily="34" charset="-120"/>
-              </a:rPr>
-              <a:t>A junior asks, two matched seniors answer, and neither learns who the other is</a:t>
+                <a:latin typeface="Space Grotesk" pitchFamily="34" charset="0"/>
+                <a:ea typeface="Space Grotesk" pitchFamily="34" charset="-122"/>
+                <a:cs typeface="Space Grotesk" pitchFamily="34" charset="-120"/>
+              </a:rPr>
+              <a:t>A junior asks, two matched seniors answer, and identities stay hidden</a:t>
             </a:r>
             <a:endParaRPr lang="en-US" sz="2800" dirty="0"/>
           </a:p>
@@ -3938,9 +3938,9 @@
                 <a:solidFill>
                   <a:srgbClr val="FFFFFF"/>
                 </a:solidFill>
-                <a:latin typeface="Arial" pitchFamily="34" charset="0"/>
-                <a:ea typeface="Arial" pitchFamily="34" charset="-122"/>
-                <a:cs typeface="Arial" pitchFamily="34" charset="-120"/>
+                <a:latin typeface="Space Grotesk" pitchFamily="34" charset="0"/>
+                <a:ea typeface="Space Grotesk" pitchFamily="34" charset="-122"/>
+                <a:cs typeface="Space Grotesk" pitchFamily="34" charset="-120"/>
               </a:rPr>
               <a:t>1</a:t>
             </a:r>
@@ -3980,9 +3980,9 @@
                 <a:solidFill>
                   <a:srgbClr val="26231F"/>
                 </a:solidFill>
-                <a:latin typeface="Arial" pitchFamily="34" charset="0"/>
-                <a:ea typeface="Arial" pitchFamily="34" charset="-122"/>
-                <a:cs typeface="Arial" pitchFamily="34" charset="-120"/>
+                <a:latin typeface="Space Grotesk" pitchFamily="34" charset="0"/>
+                <a:ea typeface="Space Grotesk" pitchFamily="34" charset="-122"/>
+                <a:cs typeface="Space Grotesk" pitchFamily="34" charset="-120"/>
               </a:rPr>
               <a:t>Attach a deal</a:t>
             </a:r>
@@ -4000,9 +4000,9 @@
                 <a:solidFill>
                   <a:srgbClr val="5F5A52"/>
                 </a:solidFill>
-                <a:latin typeface="Arial" pitchFamily="34" charset="0"/>
-                <a:ea typeface="Arial" pitchFamily="34" charset="-122"/>
-                <a:cs typeface="Arial" pitchFamily="34" charset="-120"/>
+                <a:latin typeface="Space Grotesk" pitchFamily="34" charset="0"/>
+                <a:ea typeface="Space Grotesk" pitchFamily="34" charset="-122"/>
+                <a:cs typeface="Space Grotesk" pitchFamily="34" charset="-120"/>
               </a:rPr>
               <a:t>Pick it from the firm's deal database, with its files</a:t>
             </a:r>
@@ -4039,9 +4039,9 @@
                 <a:solidFill>
                   <a:srgbClr val="FF7A2F"/>
                 </a:solidFill>
-                <a:latin typeface="Arial" pitchFamily="34" charset="0"/>
-                <a:ea typeface="Arial" pitchFamily="34" charset="-122"/>
-                <a:cs typeface="Arial" pitchFamily="34" charset="-120"/>
+                <a:latin typeface="Space Grotesk" pitchFamily="34" charset="0"/>
+                <a:ea typeface="Space Grotesk" pitchFamily="34" charset="-122"/>
+                <a:cs typeface="Space Grotesk" pitchFamily="34" charset="-120"/>
               </a:rPr>
               <a:t>→</a:t>
             </a:r>
@@ -4137,9 +4137,9 @@
                 <a:solidFill>
                   <a:srgbClr val="FFFFFF"/>
                 </a:solidFill>
-                <a:latin typeface="Arial" pitchFamily="34" charset="0"/>
-                <a:ea typeface="Arial" pitchFamily="34" charset="-122"/>
-                <a:cs typeface="Arial" pitchFamily="34" charset="-120"/>
+                <a:latin typeface="Space Grotesk" pitchFamily="34" charset="0"/>
+                <a:ea typeface="Space Grotesk" pitchFamily="34" charset="-122"/>
+                <a:cs typeface="Space Grotesk" pitchFamily="34" charset="-120"/>
               </a:rPr>
               <a:t>2</a:t>
             </a:r>
@@ -4179,9 +4179,9 @@
                 <a:solidFill>
                   <a:srgbClr val="26231F"/>
                 </a:solidFill>
-                <a:latin typeface="Arial" pitchFamily="34" charset="0"/>
-                <a:ea typeface="Arial" pitchFamily="34" charset="-122"/>
-                <a:cs typeface="Arial" pitchFamily="34" charset="-120"/>
+                <a:latin typeface="Space Grotesk" pitchFamily="34" charset="0"/>
+                <a:ea typeface="Space Grotesk" pitchFamily="34" charset="-122"/>
+                <a:cs typeface="Space Grotesk" pitchFamily="34" charset="-120"/>
               </a:rPr>
               <a:t>Names become codenames</a:t>
             </a:r>
@@ -4199,9 +4199,9 @@
                 <a:solidFill>
                   <a:srgbClr val="5F5A52"/>
                 </a:solidFill>
-                <a:latin typeface="Arial" pitchFamily="34" charset="0"/>
-                <a:ea typeface="Arial" pitchFamily="34" charset="-122"/>
-                <a:cs typeface="Arial" pitchFamily="34" charset="-120"/>
+                <a:latin typeface="Space Grotesk" pitchFamily="34" charset="0"/>
+                <a:ea typeface="Space Grotesk" pitchFamily="34" charset="-122"/>
+                <a:cs typeface="Space Grotesk" pitchFamily="34" charset="-120"/>
               </a:rPr>
               <a:t>“Northwind” becomes “Project Falcon (Buyer)” before anyone reads it</a:t>
             </a:r>
@@ -4238,9 +4238,9 @@
                 <a:solidFill>
                   <a:srgbClr val="FF7A2F"/>
                 </a:solidFill>
-                <a:latin typeface="Arial" pitchFamily="34" charset="0"/>
-                <a:ea typeface="Arial" pitchFamily="34" charset="-122"/>
-                <a:cs typeface="Arial" pitchFamily="34" charset="-120"/>
+                <a:latin typeface="Space Grotesk" pitchFamily="34" charset="0"/>
+                <a:ea typeface="Space Grotesk" pitchFamily="34" charset="-122"/>
+                <a:cs typeface="Space Grotesk" pitchFamily="34" charset="-120"/>
               </a:rPr>
               <a:t>→</a:t>
             </a:r>
@@ -4336,9 +4336,9 @@
                 <a:solidFill>
                   <a:srgbClr val="FFFFFF"/>
                 </a:solidFill>
-                <a:latin typeface="Arial" pitchFamily="34" charset="0"/>
-                <a:ea typeface="Arial" pitchFamily="34" charset="-122"/>
-                <a:cs typeface="Arial" pitchFamily="34" charset="-120"/>
+                <a:latin typeface="Space Grotesk" pitchFamily="34" charset="0"/>
+                <a:ea typeface="Space Grotesk" pitchFamily="34" charset="-122"/>
+                <a:cs typeface="Space Grotesk" pitchFamily="34" charset="-120"/>
               </a:rPr>
               <a:t>3</a:t>
             </a:r>
@@ -4378,9 +4378,9 @@
                 <a:solidFill>
                   <a:srgbClr val="26231F"/>
                 </a:solidFill>
-                <a:latin typeface="Arial" pitchFamily="34" charset="0"/>
-                <a:ea typeface="Arial" pitchFamily="34" charset="-122"/>
-                <a:cs typeface="Arial" pitchFamily="34" charset="-120"/>
+                <a:latin typeface="Space Grotesk" pitchFamily="34" charset="0"/>
+                <a:ea typeface="Space Grotesk" pitchFamily="34" charset="-122"/>
+                <a:cs typeface="Space Grotesk" pitchFamily="34" charset="-120"/>
               </a:rPr>
               <a:t>Routed to 2 seniors</a:t>
             </a:r>
@@ -4398,9 +4398,9 @@
                 <a:solidFill>
                   <a:srgbClr val="5F5A52"/>
                 </a:solidFill>
-                <a:latin typeface="Arial" pitchFamily="34" charset="0"/>
-                <a:ea typeface="Arial" pitchFamily="34" charset="-122"/>
-                <a:cs typeface="Arial" pitchFamily="34" charset="-120"/>
+                <a:latin typeface="Space Grotesk" pitchFamily="34" charset="0"/>
+                <a:ea typeface="Space Grotesk" pitchFamily="34" charset="-122"/>
+                <a:cs typeface="Space Grotesk" pitchFamily="34" charset="-120"/>
               </a:rPr>
               <a:t>Matched by deal type and sector</a:t>
             </a:r>
@@ -4437,9 +4437,9 @@
                 <a:solidFill>
                   <a:srgbClr val="FF7A2F"/>
                 </a:solidFill>
-                <a:latin typeface="Arial" pitchFamily="34" charset="0"/>
-                <a:ea typeface="Arial" pitchFamily="34" charset="-122"/>
-                <a:cs typeface="Arial" pitchFamily="34" charset="-120"/>
+                <a:latin typeface="Space Grotesk" pitchFamily="34" charset="0"/>
+                <a:ea typeface="Space Grotesk" pitchFamily="34" charset="-122"/>
+                <a:cs typeface="Space Grotesk" pitchFamily="34" charset="-120"/>
               </a:rPr>
               <a:t>→</a:t>
             </a:r>
@@ -4535,9 +4535,9 @@
                 <a:solidFill>
                   <a:srgbClr val="FFFFFF"/>
                 </a:solidFill>
-                <a:latin typeface="Arial" pitchFamily="34" charset="0"/>
-                <a:ea typeface="Arial" pitchFamily="34" charset="-122"/>
-                <a:cs typeface="Arial" pitchFamily="34" charset="-120"/>
+                <a:latin typeface="Space Grotesk" pitchFamily="34" charset="0"/>
+                <a:ea typeface="Space Grotesk" pitchFamily="34" charset="-122"/>
+                <a:cs typeface="Space Grotesk" pitchFamily="34" charset="-120"/>
               </a:rPr>
               <a:t>4</a:t>
             </a:r>
@@ -4577,9 +4577,9 @@
                 <a:solidFill>
                   <a:srgbClr val="26231F"/>
                 </a:solidFill>
-                <a:latin typeface="Arial" pitchFamily="34" charset="0"/>
-                <a:ea typeface="Arial" pitchFamily="34" charset="-122"/>
-                <a:cs typeface="Arial" pitchFamily="34" charset="-120"/>
+                <a:latin typeface="Space Grotesk" pitchFamily="34" charset="0"/>
+                <a:ea typeface="Space Grotesk" pitchFamily="34" charset="-122"/>
+                <a:cs typeface="Space Grotesk" pitchFamily="34" charset="-120"/>
               </a:rPr>
               <a:t>Answer comes back</a:t>
             </a:r>
@@ -4597,9 +4597,9 @@
                 <a:solidFill>
                   <a:srgbClr val="5F5A52"/>
                 </a:solidFill>
-                <a:latin typeface="Arial" pitchFamily="34" charset="0"/>
-                <a:ea typeface="Arial" pitchFamily="34" charset="-122"/>
-                <a:cs typeface="Arial" pitchFamily="34" charset="-120"/>
+                <a:latin typeface="Space Grotesk" pitchFamily="34" charset="0"/>
+                <a:ea typeface="Space Grotesk" pitchFamily="34" charset="-122"/>
+                <a:cs typeface="Space Grotesk" pitchFamily="34" charset="-120"/>
               </a:rPr>
               <a:t>Bottom line, their words, why, and what to watch</a:t>
             </a:r>
@@ -4663,9 +4663,9 @@
                 <a:solidFill>
                   <a:srgbClr val="FFFFFF"/>
                 </a:solidFill>
-                <a:latin typeface="Arial" pitchFamily="34" charset="0"/>
-                <a:ea typeface="Arial" pitchFamily="34" charset="-122"/>
-                <a:cs typeface="Arial" pitchFamily="34" charset="-120"/>
+                <a:latin typeface="Space Grotesk" pitchFamily="34" charset="0"/>
+                <a:ea typeface="Space Grotesk" pitchFamily="34" charset="-122"/>
+                <a:cs typeface="Space Grotesk" pitchFamily="34" charset="-120"/>
               </a:rPr>
               <a:t>Everyone sees only an anonymous handle and a level.  </a:t>
             </a:r>
@@ -4677,9 +4677,9 @@
                 <a:solidFill>
                   <a:srgbClr val="D9D2C5"/>
                 </a:solidFill>
-                <a:latin typeface="Arial" pitchFamily="34" charset="0"/>
-                <a:ea typeface="Arial" pitchFamily="34" charset="-122"/>
-                <a:cs typeface="Arial" pitchFamily="34" charset="-120"/>
+                <a:latin typeface="Space Grotesk" pitchFamily="34" charset="0"/>
+                <a:ea typeface="Space Grotesk" pitchFamily="34" charset="-122"/>
+                <a:cs typeface="Space Grotesk" pitchFamily="34" charset="-120"/>
               </a:rPr>
               <a:t>Compliance keeps a sealed copy it can open if regulators ask.</a:t>
             </a:r>
@@ -4748,9 +4748,9 @@
                 <a:solidFill>
                   <a:srgbClr val="FF7A2F"/>
                 </a:solidFill>
-                <a:latin typeface="Arial" pitchFamily="34" charset="0"/>
-                <a:ea typeface="Arial" pitchFamily="34" charset="-122"/>
-                <a:cs typeface="Arial" pitchFamily="34" charset="-120"/>
+                <a:latin typeface="Space Grotesk" pitchFamily="34" charset="0"/>
+                <a:ea typeface="Space Grotesk" pitchFamily="34" charset="-122"/>
+                <a:cs typeface="Space Grotesk" pitchFamily="34" charset="-120"/>
               </a:rPr>
               <a:t>THE PRODUCT</a:t>
             </a:r>
@@ -4787,9 +4787,9 @@
                 <a:solidFill>
                   <a:srgbClr val="26231F"/>
                 </a:solidFill>
-                <a:latin typeface="Arial" pitchFamily="34" charset="0"/>
-                <a:ea typeface="Arial" pitchFamily="34" charset="-122"/>
-                <a:cs typeface="Arial" pitchFamily="34" charset="-120"/>
+                <a:latin typeface="Space Grotesk" pitchFamily="34" charset="0"/>
+                <a:ea typeface="Space Grotesk" pitchFamily="34" charset="-122"/>
+                <a:cs typeface="Space Grotesk" pitchFamily="34" charset="-120"/>
               </a:rPr>
               <a:t>A junior attaches the deal and asks in plain words</a:t>
             </a:r>
@@ -4857,9 +4857,9 @@
                 <a:solidFill>
                   <a:srgbClr val="26231F"/>
                 </a:solidFill>
-                <a:latin typeface="Arial" pitchFamily="34" charset="0"/>
-                <a:ea typeface="Arial" pitchFamily="34" charset="-122"/>
-                <a:cs typeface="Arial" pitchFamily="34" charset="-120"/>
+                <a:latin typeface="Space Grotesk" pitchFamily="34" charset="0"/>
+                <a:ea typeface="Space Grotesk" pitchFamily="34" charset="-122"/>
+                <a:cs typeface="Space Grotesk" pitchFamily="34" charset="-120"/>
               </a:rPr>
               <a:t>Deal database</a:t>
             </a:r>
@@ -4874,9 +4874,9 @@
                 <a:solidFill>
                   <a:srgbClr val="5F5A52"/>
                 </a:solidFill>
-                <a:latin typeface="Arial" pitchFamily="34" charset="0"/>
-                <a:ea typeface="Arial" pitchFamily="34" charset="-122"/>
-                <a:cs typeface="Arial" pitchFamily="34" charset="-120"/>
+                <a:latin typeface="Space Grotesk" pitchFamily="34" charset="0"/>
+                <a:ea typeface="Space Grotesk" pitchFamily="34" charset="-122"/>
+                <a:cs typeface="Space Grotesk" pitchFamily="34" charset="-120"/>
               </a:rPr>
               <a:t>10 deals: mergers, LBOs, spin-offs, hostile bids, earnings events</a:t>
             </a:r>
@@ -4891,9 +4891,9 @@
                 <a:solidFill>
                   <a:srgbClr val="26231F"/>
                 </a:solidFill>
-                <a:latin typeface="Arial" pitchFamily="34" charset="0"/>
-                <a:ea typeface="Arial" pitchFamily="34" charset="-122"/>
-                <a:cs typeface="Arial" pitchFamily="34" charset="-120"/>
+                <a:latin typeface="Space Grotesk" pitchFamily="34" charset="0"/>
+                <a:ea typeface="Space Grotesk" pitchFamily="34" charset="-122"/>
+                <a:cs typeface="Space Grotesk" pitchFamily="34" charset="-120"/>
               </a:rPr>
               <a:t> </a:t>
             </a:r>
@@ -4908,9 +4908,9 @@
                 <a:solidFill>
                   <a:srgbClr val="26231F"/>
                 </a:solidFill>
-                <a:latin typeface="Arial" pitchFamily="34" charset="0"/>
-                <a:ea typeface="Arial" pitchFamily="34" charset="-122"/>
-                <a:cs typeface="Arial" pitchFamily="34" charset="-120"/>
+                <a:latin typeface="Space Grotesk" pitchFamily="34" charset="0"/>
+                <a:ea typeface="Space Grotesk" pitchFamily="34" charset="-122"/>
+                <a:cs typeface="Space Grotesk" pitchFamily="34" charset="-120"/>
               </a:rPr>
               <a:t>Files come along</a:t>
             </a:r>
@@ -4925,9 +4925,9 @@
                 <a:solidFill>
                   <a:srgbClr val="5F5A52"/>
                 </a:solidFill>
-                <a:latin typeface="Arial" pitchFamily="34" charset="0"/>
-                <a:ea typeface="Arial" pitchFamily="34" charset="-122"/>
-                <a:cs typeface="Arial" pitchFamily="34" charset="-120"/>
+                <a:latin typeface="Space Grotesk" pitchFamily="34" charset="0"/>
+                <a:ea typeface="Space Grotesk" pitchFamily="34" charset="-122"/>
+                <a:cs typeface="Space Grotesk" pitchFamily="34" charset="-120"/>
               </a:rPr>
               <a:t>Term sheet, model notes, timeline, or the junior's own file</a:t>
             </a:r>
@@ -4942,9 +4942,9 @@
                 <a:solidFill>
                   <a:srgbClr val="26231F"/>
                 </a:solidFill>
-                <a:latin typeface="Arial" pitchFamily="34" charset="0"/>
-                <a:ea typeface="Arial" pitchFamily="34" charset="-122"/>
-                <a:cs typeface="Arial" pitchFamily="34" charset="-120"/>
+                <a:latin typeface="Space Grotesk" pitchFamily="34" charset="0"/>
+                <a:ea typeface="Space Grotesk" pitchFamily="34" charset="-122"/>
+                <a:cs typeface="Space Grotesk" pitchFamily="34" charset="-120"/>
               </a:rPr>
               <a:t> </a:t>
             </a:r>
@@ -4959,9 +4959,9 @@
                 <a:solidFill>
                   <a:srgbClr val="26231F"/>
                 </a:solidFill>
-                <a:latin typeface="Arial" pitchFamily="34" charset="0"/>
-                <a:ea typeface="Arial" pitchFamily="34" charset="-122"/>
-                <a:cs typeface="Arial" pitchFamily="34" charset="-120"/>
+                <a:latin typeface="Space Grotesk" pitchFamily="34" charset="0"/>
+                <a:ea typeface="Space Grotesk" pitchFamily="34" charset="-122"/>
+                <a:cs typeface="Space Grotesk" pitchFamily="34" charset="-120"/>
               </a:rPr>
               <a:t>The junior sees what seniors will see</a:t>
             </a:r>
@@ -4976,9 +4976,9 @@
                 <a:solidFill>
                   <a:srgbClr val="5F5A52"/>
                 </a:solidFill>
-                <a:latin typeface="Arial" pitchFamily="34" charset="0"/>
-                <a:ea typeface="Arial" pitchFamily="34" charset="-122"/>
-                <a:cs typeface="Arial" pitchFamily="34" charset="-120"/>
+                <a:latin typeface="Space Grotesk" pitchFamily="34" charset="0"/>
+                <a:ea typeface="Space Grotesk" pitchFamily="34" charset="-122"/>
+                <a:cs typeface="Space Grotesk" pitchFamily="34" charset="-120"/>
               </a:rPr>
               <a:t>An anonymous handle and level, never a name</a:t>
             </a:r>
@@ -5047,9 +5047,9 @@
                 <a:solidFill>
                   <a:srgbClr val="FF7A2F"/>
                 </a:solidFill>
-                <a:latin typeface="Arial" pitchFamily="34" charset="0"/>
-                <a:ea typeface="Arial" pitchFamily="34" charset="-122"/>
-                <a:cs typeface="Arial" pitchFamily="34" charset="-120"/>
+                <a:latin typeface="Space Grotesk" pitchFamily="34" charset="0"/>
+                <a:ea typeface="Space Grotesk" pitchFamily="34" charset="-122"/>
+                <a:cs typeface="Space Grotesk" pitchFamily="34" charset="-120"/>
               </a:rPr>
               <a:t>THE ANSWER</a:t>
             </a:r>
@@ -5086,11 +5086,11 @@
                 <a:solidFill>
                   <a:srgbClr val="26231F"/>
                 </a:solidFill>
-                <a:latin typeface="Arial" pitchFamily="34" charset="0"/>
-                <a:ea typeface="Arial" pitchFamily="34" charset="-122"/>
-                <a:cs typeface="Arial" pitchFamily="34" charset="-120"/>
-              </a:rPr>
-              <a:t>Seniors reply in their own words, and the junior gets a short, structured answer</a:t>
+                <a:latin typeface="Space Grotesk" pitchFamily="34" charset="0"/>
+                <a:ea typeface="Space Grotesk" pitchFamily="34" charset="-122"/>
+                <a:cs typeface="Space Grotesk" pitchFamily="34" charset="-120"/>
+              </a:rPr>
+              <a:t>Seniors reply in plain words, and the junior gets a structured answer</a:t>
             </a:r>
             <a:endParaRPr lang="en-US" sz="2800" dirty="0"/>
           </a:p>
@@ -5156,9 +5156,9 @@
                 <a:solidFill>
                   <a:srgbClr val="26231F"/>
                 </a:solidFill>
-                <a:latin typeface="Arial" pitchFamily="34" charset="0"/>
-                <a:ea typeface="Arial" pitchFamily="34" charset="-122"/>
-                <a:cs typeface="Arial" pitchFamily="34" charset="-120"/>
+                <a:latin typeface="Space Grotesk" pitchFamily="34" charset="0"/>
+                <a:ea typeface="Space Grotesk" pitchFamily="34" charset="-122"/>
+                <a:cs typeface="Space Grotesk" pitchFamily="34" charset="-120"/>
               </a:rPr>
               <a:t>Formatted like a Sense AI result</a:t>
             </a:r>
@@ -5173,9 +5173,9 @@
                 <a:solidFill>
                   <a:srgbClr val="5F5A52"/>
                 </a:solidFill>
-                <a:latin typeface="Arial" pitchFamily="34" charset="0"/>
-                <a:ea typeface="Arial" pitchFamily="34" charset="-122"/>
-                <a:cs typeface="Arial" pitchFamily="34" charset="-120"/>
+                <a:latin typeface="Space Grotesk" pitchFamily="34" charset="0"/>
+                <a:ea typeface="Space Grotesk" pitchFamily="34" charset="-122"/>
+                <a:cs typeface="Space Grotesk" pitchFamily="34" charset="-120"/>
               </a:rPr>
               <a:t>Bottom line, quotes, why, watch-outs</a:t>
             </a:r>
@@ -5190,9 +5190,9 @@
                 <a:solidFill>
                   <a:srgbClr val="26231F"/>
                 </a:solidFill>
-                <a:latin typeface="Arial" pitchFamily="34" charset="0"/>
-                <a:ea typeface="Arial" pitchFamily="34" charset="-122"/>
-                <a:cs typeface="Arial" pitchFamily="34" charset="-120"/>
+                <a:latin typeface="Space Grotesk" pitchFamily="34" charset="0"/>
+                <a:ea typeface="Space Grotesk" pitchFamily="34" charset="-122"/>
+                <a:cs typeface="Space Grotesk" pitchFamily="34" charset="-120"/>
               </a:rPr>
               <a:t> </a:t>
             </a:r>
@@ -5207,9 +5207,9 @@
                 <a:solidFill>
                   <a:srgbClr val="26231F"/>
                 </a:solidFill>
-                <a:latin typeface="Arial" pitchFamily="34" charset="0"/>
-                <a:ea typeface="Arial" pitchFamily="34" charset="-122"/>
-                <a:cs typeface="Arial" pitchFamily="34" charset="-120"/>
+                <a:latin typeface="Space Grotesk" pitchFamily="34" charset="0"/>
+                <a:ea typeface="Space Grotesk" pitchFamily="34" charset="-122"/>
+                <a:cs typeface="Space Grotesk" pitchFamily="34" charset="-120"/>
               </a:rPr>
               <a:t>Seniors write normally</a:t>
             </a:r>
@@ -5224,9 +5224,9 @@
                 <a:solidFill>
                   <a:srgbClr val="5F5A52"/>
                 </a:solidFill>
-                <a:latin typeface="Arial" pitchFamily="34" charset="0"/>
-                <a:ea typeface="Arial" pitchFamily="34" charset="-122"/>
-                <a:cs typeface="Arial" pitchFamily="34" charset="-120"/>
+                <a:latin typeface="Space Grotesk" pitchFamily="34" charset="0"/>
+                <a:ea typeface="Space Grotesk" pitchFamily="34" charset="-122"/>
+                <a:cs typeface="Space Grotesk" pitchFamily="34" charset="-120"/>
               </a:rPr>
               <a:t>Claude turns a quick reply into a clear answer</a:t>
             </a:r>
@@ -5241,9 +5241,9 @@
                 <a:solidFill>
                   <a:srgbClr val="26231F"/>
                 </a:solidFill>
-                <a:latin typeface="Arial" pitchFamily="34" charset="0"/>
-                <a:ea typeface="Arial" pitchFamily="34" charset="-122"/>
-                <a:cs typeface="Arial" pitchFamily="34" charset="-120"/>
+                <a:latin typeface="Space Grotesk" pitchFamily="34" charset="0"/>
+                <a:ea typeface="Space Grotesk" pitchFamily="34" charset="-122"/>
+                <a:cs typeface="Space Grotesk" pitchFamily="34" charset="-120"/>
               </a:rPr>
               <a:t> </a:t>
             </a:r>
@@ -5258,9 +5258,9 @@
                 <a:solidFill>
                   <a:srgbClr val="26231F"/>
                 </a:solidFill>
-                <a:latin typeface="Arial" pitchFamily="34" charset="0"/>
-                <a:ea typeface="Arial" pitchFamily="34" charset="-122"/>
-                <a:cs typeface="Arial" pitchFamily="34" charset="-120"/>
+                <a:latin typeface="Space Grotesk" pitchFamily="34" charset="0"/>
+                <a:ea typeface="Space Grotesk" pitchFamily="34" charset="-122"/>
+                <a:cs typeface="Space Grotesk" pitchFamily="34" charset="-120"/>
               </a:rPr>
               <a:t>Two views per question</a:t>
             </a:r>
@@ -5275,9 +5275,9 @@
                 <a:solidFill>
                   <a:srgbClr val="5F5A52"/>
                 </a:solidFill>
-                <a:latin typeface="Arial" pitchFamily="34" charset="0"/>
-                <a:ea typeface="Arial" pitchFamily="34" charset="-122"/>
-                <a:cs typeface="Arial" pitchFamily="34" charset="-120"/>
+                <a:latin typeface="Space Grotesk" pitchFamily="34" charset="0"/>
+                <a:ea typeface="Space Grotesk" pitchFamily="34" charset="-122"/>
+                <a:cs typeface="Space Grotesk" pitchFamily="34" charset="-120"/>
               </a:rPr>
               <a:t>A summary shows where the seniors agree</a:t>
             </a:r>
@@ -5346,9 +5346,9 @@
                 <a:solidFill>
                   <a:srgbClr val="FF7A2F"/>
                 </a:solidFill>
-                <a:latin typeface="Arial" pitchFamily="34" charset="0"/>
-                <a:ea typeface="Arial" pitchFamily="34" charset="-122"/>
-                <a:cs typeface="Arial" pitchFamily="34" charset="-120"/>
+                <a:latin typeface="Space Grotesk" pitchFamily="34" charset="0"/>
+                <a:ea typeface="Space Grotesk" pitchFamily="34" charset="-122"/>
+                <a:cs typeface="Space Grotesk" pitchFamily="34" charset="-120"/>
               </a:rPr>
               <a:t>DEMAND</a:t>
             </a:r>
@@ -5385,11 +5385,11 @@
                 <a:solidFill>
                   <a:srgbClr val="26231F"/>
                 </a:solidFill>
-                <a:latin typeface="Arial" pitchFamily="34" charset="0"/>
-                <a:ea typeface="Arial" pitchFamily="34" charset="-122"/>
-                <a:cs typeface="Arial" pitchFamily="34" charset="-120"/>
-              </a:rPr>
-              <a:t>Professionals already use anonymous channels and lose time waiting for answers</a:t>
+                <a:latin typeface="Space Grotesk" pitchFamily="34" charset="0"/>
+                <a:ea typeface="Space Grotesk" pitchFamily="34" charset="-122"/>
+                <a:cs typeface="Space Grotesk" pitchFamily="34" charset="-120"/>
+              </a:rPr>
+              <a:t>Professionals already use anonymous channels at work</a:t>
             </a:r>
             <a:endParaRPr lang="en-US" sz="2800" dirty="0"/>
           </a:p>
@@ -5458,9 +5458,9 @@
                 <a:solidFill>
                   <a:srgbClr val="FF7A2F"/>
                 </a:solidFill>
-                <a:latin typeface="Arial" pitchFamily="34" charset="0"/>
-                <a:ea typeface="Arial" pitchFamily="34" charset="-122"/>
-                <a:cs typeface="Arial" pitchFamily="34" charset="-120"/>
+                <a:latin typeface="Space Grotesk" pitchFamily="34" charset="0"/>
+                <a:ea typeface="Space Grotesk" pitchFamily="34" charset="-122"/>
+                <a:cs typeface="Space Grotesk" pitchFamily="34" charset="-120"/>
               </a:rPr>
               <a:t>7M+</a:t>
             </a:r>
@@ -5497,9 +5497,9 @@
                 <a:solidFill>
                   <a:srgbClr val="26231F"/>
                 </a:solidFill>
-                <a:latin typeface="Arial" pitchFamily="34" charset="0"/>
-                <a:ea typeface="Arial" pitchFamily="34" charset="-122"/>
-                <a:cs typeface="Arial" pitchFamily="34" charset="-120"/>
+                <a:latin typeface="Space Grotesk" pitchFamily="34" charset="0"/>
+                <a:ea typeface="Space Grotesk" pitchFamily="34" charset="-122"/>
+                <a:cs typeface="Space Grotesk" pitchFamily="34" charset="-120"/>
               </a:rPr>
               <a:t>verified professionals use Blind, an anonymous work app most popular in tech, finance and consulting¹</a:t>
             </a:r>
@@ -5570,9 +5570,9 @@
                 <a:solidFill>
                   <a:srgbClr val="FF7A2F"/>
                 </a:solidFill>
-                <a:latin typeface="Arial" pitchFamily="34" charset="0"/>
-                <a:ea typeface="Arial" pitchFamily="34" charset="-122"/>
-                <a:cs typeface="Arial" pitchFamily="34" charset="-120"/>
+                <a:latin typeface="Space Grotesk" pitchFamily="34" charset="0"/>
+                <a:ea typeface="Space Grotesk" pitchFamily="34" charset="-122"/>
+                <a:cs typeface="Space Grotesk" pitchFamily="34" charset="-120"/>
               </a:rPr>
               <a:t>53%</a:t>
             </a:r>
@@ -5609,9 +5609,9 @@
                 <a:solidFill>
                   <a:srgbClr val="26231F"/>
                 </a:solidFill>
-                <a:latin typeface="Arial" pitchFamily="34" charset="0"/>
-                <a:ea typeface="Arial" pitchFamily="34" charset="-122"/>
-                <a:cs typeface="Arial" pitchFamily="34" charset="-120"/>
+                <a:latin typeface="Space Grotesk" pitchFamily="34" charset="0"/>
+                <a:ea typeface="Space Grotesk" pitchFamily="34" charset="-122"/>
+                <a:cs typeface="Space Grotesk" pitchFamily="34" charset="-120"/>
               </a:rPr>
               <a:t>of 28,747 professionals say waiting on answers interrupts their work²</a:t>
             </a:r>
@@ -5682,9 +5682,9 @@
                 <a:solidFill>
                   <a:srgbClr val="FF7A2F"/>
                 </a:solidFill>
-                <a:latin typeface="Arial" pitchFamily="34" charset="0"/>
-                <a:ea typeface="Arial" pitchFamily="34" charset="-122"/>
-                <a:cs typeface="Arial" pitchFamily="34" charset="-120"/>
+                <a:latin typeface="Space Grotesk" pitchFamily="34" charset="0"/>
+                <a:ea typeface="Space Grotesk" pitchFamily="34" charset="-122"/>
+                <a:cs typeface="Space Grotesk" pitchFamily="34" charset="-120"/>
               </a:rPr>
               <a:t>49%</a:t>
             </a:r>
@@ -5721,9 +5721,9 @@
                 <a:solidFill>
                   <a:srgbClr val="26231F"/>
                 </a:solidFill>
-                <a:latin typeface="Arial" pitchFamily="34" charset="0"/>
-                <a:ea typeface="Arial" pitchFamily="34" charset="-122"/>
-                <a:cs typeface="Arial" pitchFamily="34" charset="-120"/>
+                <a:latin typeface="Space Grotesk" pitchFamily="34" charset="0"/>
+                <a:ea typeface="Space Grotesk" pitchFamily="34" charset="-122"/>
+                <a:cs typeface="Space Grotesk" pitchFamily="34" charset="-120"/>
               </a:rPr>
               <a:t>often answer questions they have already answered before²</a:t>
             </a:r>
@@ -5760,9 +5760,9 @@
                 <a:solidFill>
                   <a:srgbClr val="9A9387"/>
                 </a:solidFill>
-                <a:latin typeface="Arial" pitchFamily="34" charset="0"/>
-                <a:ea typeface="Arial" pitchFamily="34" charset="-122"/>
-                <a:cs typeface="Arial" pitchFamily="34" charset="-120"/>
+                <a:latin typeface="Space Grotesk" pitchFamily="34" charset="0"/>
+                <a:ea typeface="Space Grotesk" pitchFamily="34" charset="-122"/>
+                <a:cs typeface="Space Grotesk" pitchFamily="34" charset="-120"/>
               </a:rPr>
               <a:t>¹ Blind company blog; Fortune, Apr 2022. ² Stack Overflow Developer Survey 2024, professional developers.</a:t>
             </a:r>
@@ -5831,9 +5831,9 @@
                 <a:solidFill>
                   <a:srgbClr val="FF7A2F"/>
                 </a:solidFill>
-                <a:latin typeface="Arial" pitchFamily="34" charset="0"/>
-                <a:ea typeface="Arial" pitchFamily="34" charset="-122"/>
-                <a:cs typeface="Arial" pitchFamily="34" charset="-120"/>
+                <a:latin typeface="Space Grotesk" pitchFamily="34" charset="0"/>
+                <a:ea typeface="Space Grotesk" pitchFamily="34" charset="-122"/>
+                <a:cs typeface="Space Grotesk" pitchFamily="34" charset="-120"/>
               </a:rPr>
               <a:t>WHAT TESTERS TOLD US</a:t>
             </a:r>
@@ -5870,9 +5870,9 @@
                 <a:solidFill>
                   <a:srgbClr val="26231F"/>
                 </a:solidFill>
-                <a:latin typeface="Arial" pitchFamily="34" charset="0"/>
-                <a:ea typeface="Arial" pitchFamily="34" charset="-122"/>
-                <a:cs typeface="Arial" pitchFamily="34" charset="-120"/>
+                <a:latin typeface="Space Grotesk" pitchFamily="34" charset="0"/>
+                <a:ea typeface="Space Grotesk" pitchFamily="34" charset="-122"/>
+                <a:cs typeface="Space Grotesk" pitchFamily="34" charset="-120"/>
               </a:rPr>
               <a:t>Finance testers worry about names leaking and about IT approval</a:t>
             </a:r>
@@ -5946,9 +5946,9 @@
                 <a:solidFill>
                   <a:srgbClr val="26231F"/>
                 </a:solidFill>
-                <a:latin typeface="Arial" pitchFamily="34" charset="0"/>
-                <a:ea typeface="Arial" pitchFamily="34" charset="-122"/>
-                <a:cs typeface="Arial" pitchFamily="34" charset="-120"/>
+                <a:latin typeface="Space Grotesk" pitchFamily="34" charset="0"/>
+                <a:ea typeface="Space Grotesk" pitchFamily="34" charset="-122"/>
+                <a:cs typeface="Space Grotesk" pitchFamily="34" charset="-120"/>
               </a:rPr>
               <a:t>“It was mentioning names, and it's not supposed to mention names in that summary.”</a:t>
             </a:r>
@@ -5966,9 +5966,9 @@
                 <a:solidFill>
                   <a:srgbClr val="5F5A52"/>
                 </a:solidFill>
-                <a:latin typeface="Arial" pitchFamily="34" charset="0"/>
-                <a:ea typeface="Arial" pitchFamily="34" charset="-122"/>
-                <a:cs typeface="Arial" pitchFamily="34" charset="-120"/>
+                <a:latin typeface="Space Grotesk" pitchFamily="34" charset="0"/>
+                <a:ea typeface="Space Grotesk" pitchFamily="34" charset="-122"/>
+                <a:cs typeface="Space Grotesk" pitchFamily="34" charset="-120"/>
               </a:rPr>
               <a:t>Tester, on an AI summary at work</a:t>
             </a:r>
@@ -6042,9 +6042,9 @@
                 <a:solidFill>
                   <a:srgbClr val="26231F"/>
                 </a:solidFill>
-                <a:latin typeface="Arial" pitchFamily="34" charset="0"/>
-                <a:ea typeface="Arial" pitchFamily="34" charset="-122"/>
-                <a:cs typeface="Arial" pitchFamily="34" charset="-120"/>
+                <a:latin typeface="Space Grotesk" pitchFamily="34" charset="0"/>
+                <a:ea typeface="Space Grotesk" pitchFamily="34" charset="-122"/>
+                <a:cs typeface="Space Grotesk" pitchFamily="34" charset="-120"/>
               </a:rPr>
               <a:t>“to use a new application or artificial intelligence, they have to go through IT. And IT has to approve it”</a:t>
             </a:r>
@@ -6062,9 +6062,9 @@
                 <a:solidFill>
                   <a:srgbClr val="5F5A52"/>
                 </a:solidFill>
-                <a:latin typeface="Arial" pitchFamily="34" charset="0"/>
-                <a:ea typeface="Arial" pitchFamily="34" charset="-122"/>
-                <a:cs typeface="Arial" pitchFamily="34" charset="-120"/>
+                <a:latin typeface="Space Grotesk" pitchFamily="34" charset="0"/>
+                <a:ea typeface="Space Grotesk" pitchFamily="34" charset="-122"/>
+                <a:cs typeface="Space Grotesk" pitchFamily="34" charset="-120"/>
               </a:rPr>
               <a:t>Same tester, on adopting new tools</a:t>
             </a:r>
@@ -6128,9 +6128,9 @@
                 <a:solidFill>
                   <a:srgbClr val="26231F"/>
                 </a:solidFill>
-                <a:latin typeface="Arial" pitchFamily="34" charset="0"/>
-                <a:ea typeface="Arial" pitchFamily="34" charset="-122"/>
-                <a:cs typeface="Arial" pitchFamily="34" charset="-120"/>
+                <a:latin typeface="Space Grotesk" pitchFamily="34" charset="0"/>
+                <a:ea typeface="Space Grotesk" pitchFamily="34" charset="-122"/>
+                <a:cs typeface="Space Grotesk" pitchFamily="34" charset="-120"/>
               </a:rPr>
               <a:t>What we built in response: </a:t>
             </a:r>
@@ -6142,9 +6142,9 @@
                 <a:solidFill>
                   <a:srgbClr val="26231F"/>
                 </a:solidFill>
-                <a:latin typeface="Arial" pitchFamily="34" charset="0"/>
-                <a:ea typeface="Arial" pitchFamily="34" charset="-122"/>
-                <a:cs typeface="Arial" pitchFamily="34" charset="-120"/>
+                <a:latin typeface="Space Grotesk" pitchFamily="34" charset="0"/>
+                <a:ea typeface="Space Grotesk" pitchFamily="34" charset="-122"/>
+                <a:cs typeface="Space Grotesk" pitchFamily="34" charset="-120"/>
               </a:rPr>
               <a:t>client names become codenames before any senior reads a question, and Deal Desk runs inside the bank with a sealed record for compliance.</a:t>
             </a:r>
@@ -6181,9 +6181,9 @@
                 <a:solidFill>
                   <a:srgbClr val="9A9387"/>
                 </a:solidFill>
-                <a:latin typeface="Arial" pitchFamily="34" charset="0"/>
-                <a:ea typeface="Arial" pitchFamily="34" charset="-122"/>
-                <a:cs typeface="Arial" pitchFamily="34" charset="-120"/>
+                <a:latin typeface="Space Grotesk" pitchFamily="34" charset="0"/>
+                <a:ea typeface="Space Grotesk" pitchFamily="34" charset="-122"/>
+                <a:cs typeface="Space Grotesk" pitchFamily="34" charset="-120"/>
               </a:rPr>
               <a:t>Sense AI phone interview with a finance tester, Oct 10, 2026.</a:t>
             </a:r>
@@ -6242,7 +6242,7 @@
     </a:clrScheme>
     <a:fontScheme name="Office">
       <a:majorFont>
-        <a:latin typeface="Arial"/>
+        <a:latin typeface="Space Grotesk"/>
         <a:ea typeface=""/>
         <a:cs typeface=""/>
         <a:font script="Jpan" typeface="游ゴシック Light"/>
@@ -6294,7 +6294,7 @@
         <a:font script="Tfng" typeface="Ebrima"/>
       </a:majorFont>
       <a:minorFont>
-        <a:latin typeface="Arial"/>
+        <a:latin typeface="Space Grotesk"/>
         <a:ea typeface=""/>
         <a:cs typeface=""/>
         <a:font script="Jpan" typeface="游ゴシック"/>

</xml_diff>

<commit_message>
Deal Desk deck: PDF version, spacing fixes on slides 6 and 7
Co-Authored-By: Claude Opus 5.5 <noreply@anthropic.com>
</commit_message>
<xml_diff>
--- a/docs/Deal-Desk.pptx
+++ b/docs/Deal-Desk.pptx
@@ -4813,8 +4813,8 @@
         </p:blipFill>
         <p:spPr>
           <a:xfrm>
-            <a:off x="457200" y="1188720"/>
-            <a:ext cx="5120640" cy="3617333"/>
+            <a:off x="457200" y="1417320"/>
+            <a:ext cx="4663440" cy="3294357"/>
           </a:xfrm>
           <a:prstGeom prst="rect">
             <a:avLst/>
@@ -4836,8 +4836,8 @@
         </p:nvSpPr>
         <p:spPr>
           <a:xfrm>
-            <a:off x="5897880" y="1234440"/>
-            <a:ext cx="2788920" cy="3474720"/>
+            <a:off x="5486400" y="1463040"/>
+            <a:ext cx="3200400" cy="3200400"/>
           </a:xfrm>
           <a:prstGeom prst="rect">
             <a:avLst/>
@@ -5112,8 +5112,8 @@
         </p:blipFill>
         <p:spPr>
           <a:xfrm>
-            <a:off x="4560693" y="1188720"/>
-            <a:ext cx="4126107" cy="3520440"/>
+            <a:off x="4560693" y="1325880"/>
+            <a:ext cx="4018935" cy="3429000"/>
           </a:xfrm>
           <a:prstGeom prst="rect">
             <a:avLst/>
@@ -5135,8 +5135,8 @@
         </p:nvSpPr>
         <p:spPr>
           <a:xfrm>
-            <a:off x="457200" y="1234440"/>
-            <a:ext cx="3291840" cy="3474720"/>
+            <a:off x="457200" y="1417320"/>
+            <a:ext cx="3291840" cy="3291840"/>
           </a:xfrm>
           <a:prstGeom prst="rect">
             <a:avLst/>

</xml_diff>